<commit_message>
Add supplied team roster and instructor-approved team size
</commit_message>
<xml_diff>
--- a/presentation/MCQA_pitch_ready.pptx
+++ b/presentation/MCQA_pitch_ready.pptx
@@ -2,22 +2,22 @@
 <file path=ppt/presentation.xml><?xml version="1.0" encoding="utf-8"?>
 <p:presentation xmlns:p="http://schemas.openxmlformats.org/presentationml/2006/main">
   <p:sldMasterIdLst>
-    <p:sldMasterId xmlns:r="http://schemas.openxmlformats.org/officeDocument/2006/relationships" id="2147483648" r:id="R2c7918411dce4703"/>
+    <p:sldMasterId xmlns:r="http://schemas.openxmlformats.org/officeDocument/2006/relationships" id="2147483648" r:id="R190b2f4b639041e4"/>
   </p:sldMasterIdLst>
   <p:notesMasterIdLst>
-    <p:notesMasterId xmlns:r="http://schemas.openxmlformats.org/officeDocument/2006/relationships" r:id="R1c8769eaf1e647d1"/>
+    <p:notesMasterId xmlns:r="http://schemas.openxmlformats.org/officeDocument/2006/relationships" r:id="R64f24ec0b94d4571"/>
   </p:notesMasterIdLst>
   <p:sldIdLst>
-    <p:sldId xmlns:r="http://schemas.openxmlformats.org/officeDocument/2006/relationships" id="256" r:id="R3b4cf3517f02450b"/>
-    <p:sldId xmlns:r="http://schemas.openxmlformats.org/officeDocument/2006/relationships" id="257" r:id="R07f739feb1814926"/>
-    <p:sldId xmlns:r="http://schemas.openxmlformats.org/officeDocument/2006/relationships" id="258" r:id="R23b784bd304f4b23"/>
-    <p:sldId xmlns:r="http://schemas.openxmlformats.org/officeDocument/2006/relationships" id="259" r:id="R8ba829a958c04a73"/>
-    <p:sldId xmlns:r="http://schemas.openxmlformats.org/officeDocument/2006/relationships" id="260" r:id="R543f4f4fa7cd4e03"/>
-    <p:sldId xmlns:r="http://schemas.openxmlformats.org/officeDocument/2006/relationships" id="261" r:id="R174ec344c8874123"/>
-    <p:sldId xmlns:r="http://schemas.openxmlformats.org/officeDocument/2006/relationships" id="262" r:id="Rd3705c2051864694"/>
-    <p:sldId xmlns:r="http://schemas.openxmlformats.org/officeDocument/2006/relationships" id="263" r:id="Rbcdf1f07338049e1"/>
-    <p:sldId xmlns:r="http://schemas.openxmlformats.org/officeDocument/2006/relationships" id="264" r:id="Rbacde573f5074cee"/>
-    <p:sldId xmlns:r="http://schemas.openxmlformats.org/officeDocument/2006/relationships" id="265" r:id="R1f8fc50dc5c042c6"/>
+    <p:sldId xmlns:r="http://schemas.openxmlformats.org/officeDocument/2006/relationships" id="256" r:id="Rfe83c29357aa4b9d"/>
+    <p:sldId xmlns:r="http://schemas.openxmlformats.org/officeDocument/2006/relationships" id="257" r:id="R18373deac7274be0"/>
+    <p:sldId xmlns:r="http://schemas.openxmlformats.org/officeDocument/2006/relationships" id="258" r:id="R8333a68fb0344e46"/>
+    <p:sldId xmlns:r="http://schemas.openxmlformats.org/officeDocument/2006/relationships" id="259" r:id="R565255f52e914b81"/>
+    <p:sldId xmlns:r="http://schemas.openxmlformats.org/officeDocument/2006/relationships" id="260" r:id="Rb5cf93e36d9147c6"/>
+    <p:sldId xmlns:r="http://schemas.openxmlformats.org/officeDocument/2006/relationships" id="261" r:id="R95b7afb8cfdc47f3"/>
+    <p:sldId xmlns:r="http://schemas.openxmlformats.org/officeDocument/2006/relationships" id="262" r:id="Rdfc8013daafd455c"/>
+    <p:sldId xmlns:r="http://schemas.openxmlformats.org/officeDocument/2006/relationships" id="263" r:id="R9352036c52514de9"/>
+    <p:sldId xmlns:r="http://schemas.openxmlformats.org/officeDocument/2006/relationships" id="264" r:id="R4944e7699a684895"/>
+    <p:sldId xmlns:r="http://schemas.openxmlformats.org/officeDocument/2006/relationships" id="265" r:id="Rd82e17622c4b444d"/>
   </p:sldIdLst>
   <p:sldSz cx="12192000" cy="6858000"/>
   <p:notesSz cx="6858000" cy="9144000"/>
@@ -1539,7 +1539,7 @@
   </p:cSld>
   <p:clrMap bg1="lt1" tx1="dk1" bg2="lt2" tx2="dk2" accent1="accent1" accent2="accent2" accent3="accent3" accent4="accent4" accent5="accent5" accent6="accent6" hlink="hlink" folHlink="folHlink"/>
   <p:sldLayoutIdLst>
-    <p:sldLayoutId xmlns:r="http://schemas.openxmlformats.org/officeDocument/2006/relationships" id="2147483649" r:id="R578d420c65ef47c4"/>
+    <p:sldLayoutId xmlns:r="http://schemas.openxmlformats.org/officeDocument/2006/relationships" id="2147483649" r:id="R252b6bb054d34730"/>
   </p:sldLayoutIdLst>
   <p:txStyles>
     <p:titleStyle>
@@ -2119,6 +2119,7 @@
           <a:lstStyle xmlns:a="http://schemas.openxmlformats.org/drawingml/2006/main"/>
           <a:p xmlns:a="http://schemas.openxmlformats.org/drawingml/2006/main">
             <a:pPr algn="r">
+              <a:buNone/>
               <a:defRPr sz="1500" b="0">
                 <a:solidFill>
                   <a:srgbClr val="A5BEAD"/>
@@ -2176,6 +2177,7 @@
           <a:lstStyle xmlns:a="http://schemas.openxmlformats.org/drawingml/2006/main"/>
           <a:p xmlns:a="http://schemas.openxmlformats.org/drawingml/2006/main">
             <a:pPr algn="l">
+              <a:buNone/>
               <a:defRPr sz="7800" b="1">
                 <a:solidFill>
                   <a:srgbClr val="FFFFFF"/>
@@ -2233,6 +2235,7 @@
           <a:lstStyle xmlns:a="http://schemas.openxmlformats.org/drawingml/2006/main"/>
           <a:p xmlns:a="http://schemas.openxmlformats.org/drawingml/2006/main">
             <a:pPr algn="l">
+              <a:buNone/>
               <a:defRPr sz="3600" b="0">
                 <a:solidFill>
                   <a:srgbClr val="FFFFFF"/>
@@ -2290,6 +2293,7 @@
           <a:lstStyle xmlns:a="http://schemas.openxmlformats.org/drawingml/2006/main"/>
           <a:p xmlns:a="http://schemas.openxmlformats.org/drawingml/2006/main">
             <a:pPr algn="l">
+              <a:buNone/>
               <a:defRPr sz="2250" b="0">
                 <a:solidFill>
                   <a:srgbClr val="CEE2D3"/>
@@ -2347,6 +2351,7 @@
           <a:lstStyle xmlns:a="http://schemas.openxmlformats.org/drawingml/2006/main"/>
           <a:p xmlns:a="http://schemas.openxmlformats.org/drawingml/2006/main">
             <a:pPr algn="l">
+              <a:buNone/>
               <a:defRPr sz="1950" b="0">
                 <a:solidFill>
                   <a:srgbClr val="A7D0B5"/>
@@ -2386,8 +2391,8 @@
         </p:nvSpPr>
         <p:spPr>
           <a:xfrm xmlns:a="http://schemas.openxmlformats.org/drawingml/2006/main">
-            <a:off x="647700" y="5810250"/>
-            <a:ext cx="10001250" cy="400050"/>
+            <a:off x="647700" y="5514975"/>
+            <a:ext cx="10001250" cy="742950"/>
           </a:xfrm>
           <a:prstGeom xmlns:a="http://schemas.openxmlformats.org/drawingml/2006/main" prst="rect">
             <a:avLst/>
@@ -2401,9 +2406,21 @@
           <a:bodyPr xmlns:a="http://schemas.openxmlformats.org/drawingml/2006/main" wrap="square" lIns="0" tIns="0" rIns="0" bIns="0">
             <a:noAutofit/>
           </a:bodyPr>
-          <a:lstStyle xmlns:a="http://schemas.openxmlformats.org/drawingml/2006/main"/>
+          <a:lstStyle xmlns:a="http://schemas.openxmlformats.org/drawingml/2006/main">
+            <a:defPPr algn="l">
+              <a:defRPr sz="1800">
+                <a:solidFill>
+                  <a:srgbClr val="FFFFFF"/>
+                </a:solidFill>
+                <a:latin typeface="Tahoma"/>
+                <a:ea typeface="Tahoma"/>
+                <a:cs typeface="Tahoma"/>
+              </a:defRPr>
+            </a:defPPr>
+          </a:lstStyle>
           <a:p xmlns:a="http://schemas.openxmlformats.org/drawingml/2006/main">
             <a:pPr algn="l">
+              <a:buNone/>
               <a:defRPr sz="1800" b="0">
                 <a:solidFill>
                   <a:srgbClr val="FFFFFF"/>
@@ -2422,7 +2439,31 @@
                 <a:ea typeface="Tahoma"/>
                 <a:cs typeface="Tahoma"/>
               </a:rPr>
-              <a:t>Team: add the real names of your 3–4 members</a:t>
+              <a:t>Natdanai Phurintanachot (67070230)</a:t>
+            </a:r>
+          </a:p>
+          <a:p xmlns:a="http://schemas.openxmlformats.org/drawingml/2006/main">
+            <a:pPr algn="l">
+              <a:buNone/>
+              <a:defRPr sz="1800" b="0">
+                <a:solidFill>
+                  <a:srgbClr val="FFFFFF"/>
+                </a:solidFill>
+                <a:latin typeface="Tahoma"/>
+                <a:ea typeface="Tahoma"/>
+                <a:cs typeface="Tahoma"/>
+              </a:defRPr>
+            </a:pPr>
+            <a:r>
+              <a:rPr sz="1800" b="0">
+                <a:solidFill>
+                  <a:srgbClr val="FFFFFF"/>
+                </a:solidFill>
+                <a:latin typeface="Tahoma"/>
+                <a:ea typeface="Tahoma"/>
+                <a:cs typeface="Tahoma"/>
+              </a:rPr>
+              <a:t>Nattapong Suphawirojlert (67070051)</a:t>
             </a:r>
           </a:p>
         </p:txBody>
@@ -2490,6 +2531,7 @@
           <a:lstStyle xmlns:a="http://schemas.openxmlformats.org/drawingml/2006/main"/>
           <a:p xmlns:a="http://schemas.openxmlformats.org/drawingml/2006/main">
             <a:pPr algn="l">
+              <a:buNone/>
               <a:defRPr sz="3300" b="1">
                 <a:solidFill>
                   <a:srgbClr val="142B2A"/>
@@ -2547,6 +2589,7 @@
           <a:lstStyle xmlns:a="http://schemas.openxmlformats.org/drawingml/2006/main"/>
           <a:p xmlns:a="http://schemas.openxmlformats.org/drawingml/2006/main">
             <a:pPr algn="r">
+              <a:buNone/>
               <a:defRPr sz="1500" b="0">
                 <a:solidFill>
                   <a:srgbClr val="536563"/>
@@ -2604,6 +2647,7 @@
           <a:lstStyle xmlns:a="http://schemas.openxmlformats.org/drawingml/2006/main"/>
           <a:p xmlns:a="http://schemas.openxmlformats.org/drawingml/2006/main">
             <a:pPr algn="l">
+              <a:buNone/>
               <a:defRPr sz="2400" b="1">
                 <a:solidFill>
                   <a:srgbClr val="24774F"/>
@@ -2661,6 +2705,7 @@
           <a:lstStyle xmlns:a="http://schemas.openxmlformats.org/drawingml/2006/main"/>
           <a:p xmlns:a="http://schemas.openxmlformats.org/drawingml/2006/main">
             <a:pPr algn="l">
+              <a:buNone/>
               <a:defRPr sz="2175" b="0">
                 <a:solidFill>
                   <a:srgbClr val="142B2A"/>
@@ -2718,6 +2763,7 @@
           <a:lstStyle xmlns:a="http://schemas.openxmlformats.org/drawingml/2006/main"/>
           <a:p xmlns:a="http://schemas.openxmlformats.org/drawingml/2006/main">
             <a:pPr algn="l">
+              <a:buNone/>
               <a:defRPr sz="2175" b="0">
                 <a:solidFill>
                   <a:srgbClr val="142B2A"/>
@@ -2775,6 +2821,7 @@
           <a:lstStyle xmlns:a="http://schemas.openxmlformats.org/drawingml/2006/main"/>
           <a:p xmlns:a="http://schemas.openxmlformats.org/drawingml/2006/main">
             <a:pPr algn="l">
+              <a:buNone/>
               <a:defRPr sz="2175" b="0">
                 <a:solidFill>
                   <a:srgbClr val="142B2A"/>
@@ -2832,6 +2879,7 @@
           <a:lstStyle xmlns:a="http://schemas.openxmlformats.org/drawingml/2006/main"/>
           <a:p xmlns:a="http://schemas.openxmlformats.org/drawingml/2006/main">
             <a:pPr algn="l">
+              <a:buNone/>
               <a:defRPr sz="2400" b="1">
                 <a:solidFill>
                   <a:srgbClr val="24774F"/>
@@ -2889,6 +2937,7 @@
           <a:lstStyle xmlns:a="http://schemas.openxmlformats.org/drawingml/2006/main"/>
           <a:p xmlns:a="http://schemas.openxmlformats.org/drawingml/2006/main">
             <a:pPr algn="l">
+              <a:buNone/>
               <a:defRPr sz="2100" b="0">
                 <a:solidFill>
                   <a:srgbClr val="142B2A"/>
@@ -2912,6 +2961,7 @@
           </a:p>
           <a:p xmlns:a="http://schemas.openxmlformats.org/drawingml/2006/main">
             <a:pPr algn="l">
+              <a:buNone/>
               <a:defRPr sz="2100" b="0">
                 <a:solidFill>
                   <a:srgbClr val="142B2A"/>
@@ -2969,6 +3019,7 @@
           <a:lstStyle xmlns:a="http://schemas.openxmlformats.org/drawingml/2006/main"/>
           <a:p xmlns:a="http://schemas.openxmlformats.org/drawingml/2006/main">
             <a:pPr algn="l">
+              <a:buNone/>
               <a:defRPr sz="1575" b="0">
                 <a:solidFill>
                   <a:srgbClr val="536563"/>
@@ -3055,6 +3106,7 @@
           <a:lstStyle xmlns:a="http://schemas.openxmlformats.org/drawingml/2006/main"/>
           <a:p xmlns:a="http://schemas.openxmlformats.org/drawingml/2006/main">
             <a:pPr algn="l">
+              <a:buNone/>
               <a:defRPr sz="3300" b="1">
                 <a:solidFill>
                   <a:srgbClr val="142B2A"/>
@@ -3112,6 +3164,7 @@
           <a:lstStyle xmlns:a="http://schemas.openxmlformats.org/drawingml/2006/main"/>
           <a:p xmlns:a="http://schemas.openxmlformats.org/drawingml/2006/main">
             <a:pPr algn="r">
+              <a:buNone/>
               <a:defRPr sz="1500" b="0">
                 <a:solidFill>
                   <a:srgbClr val="536563"/>
@@ -3169,6 +3222,7 @@
           <a:lstStyle xmlns:a="http://schemas.openxmlformats.org/drawingml/2006/main"/>
           <a:p xmlns:a="http://schemas.openxmlformats.org/drawingml/2006/main">
             <a:pPr algn="l">
+              <a:buNone/>
               <a:defRPr sz="2400" b="1">
                 <a:solidFill>
                   <a:srgbClr val="24774F"/>
@@ -3226,6 +3280,7 @@
           <a:lstStyle xmlns:a="http://schemas.openxmlformats.org/drawingml/2006/main"/>
           <a:p xmlns:a="http://schemas.openxmlformats.org/drawingml/2006/main">
             <a:pPr algn="l">
+              <a:buNone/>
               <a:defRPr sz="2700" b="0">
                 <a:solidFill>
                   <a:srgbClr val="142B2A"/>
@@ -3249,6 +3304,7 @@
           </a:p>
           <a:p xmlns:a="http://schemas.openxmlformats.org/drawingml/2006/main">
             <a:pPr algn="l">
+              <a:buNone/>
               <a:defRPr sz="2700" b="0">
                 <a:solidFill>
                   <a:srgbClr val="142B2A"/>
@@ -3306,6 +3362,7 @@
           <a:lstStyle xmlns:a="http://schemas.openxmlformats.org/drawingml/2006/main"/>
           <a:p xmlns:a="http://schemas.openxmlformats.org/drawingml/2006/main">
             <a:pPr algn="l">
+              <a:buNone/>
               <a:defRPr sz="2250" b="0">
                 <a:solidFill>
                   <a:srgbClr val="536563"/>
@@ -3329,6 +3386,7 @@
           </a:p>
           <a:p xmlns:a="http://schemas.openxmlformats.org/drawingml/2006/main">
             <a:pPr algn="l">
+              <a:buNone/>
               <a:defRPr sz="2250" b="0">
                 <a:solidFill>
                   <a:srgbClr val="536563"/>
@@ -3386,6 +3444,7 @@
           <a:lstStyle xmlns:a="http://schemas.openxmlformats.org/drawingml/2006/main"/>
           <a:p xmlns:a="http://schemas.openxmlformats.org/drawingml/2006/main">
             <a:pPr algn="l">
+              <a:buNone/>
               <a:defRPr sz="2400" b="1">
                 <a:solidFill>
                   <a:srgbClr val="24774F"/>
@@ -3443,6 +3502,7 @@
           <a:lstStyle xmlns:a="http://schemas.openxmlformats.org/drawingml/2006/main"/>
           <a:p xmlns:a="http://schemas.openxmlformats.org/drawingml/2006/main">
             <a:pPr algn="l">
+              <a:buNone/>
               <a:defRPr sz="2700" b="0">
                 <a:solidFill>
                   <a:srgbClr val="142B2A"/>
@@ -3466,6 +3526,7 @@
           </a:p>
           <a:p xmlns:a="http://schemas.openxmlformats.org/drawingml/2006/main">
             <a:pPr algn="l">
+              <a:buNone/>
               <a:defRPr sz="2700" b="0">
                 <a:solidFill>
                   <a:srgbClr val="142B2A"/>
@@ -3523,6 +3584,7 @@
           <a:lstStyle xmlns:a="http://schemas.openxmlformats.org/drawingml/2006/main"/>
           <a:p xmlns:a="http://schemas.openxmlformats.org/drawingml/2006/main">
             <a:pPr algn="l">
+              <a:buNone/>
               <a:defRPr sz="2250" b="0">
                 <a:solidFill>
                   <a:srgbClr val="536563"/>
@@ -3546,6 +3608,7 @@
           </a:p>
           <a:p xmlns:a="http://schemas.openxmlformats.org/drawingml/2006/main">
             <a:pPr algn="l">
+              <a:buNone/>
               <a:defRPr sz="2250" b="0">
                 <a:solidFill>
                   <a:srgbClr val="536563"/>
@@ -3603,6 +3666,7 @@
           <a:lstStyle xmlns:a="http://schemas.openxmlformats.org/drawingml/2006/main"/>
           <a:p xmlns:a="http://schemas.openxmlformats.org/drawingml/2006/main">
             <a:pPr algn="l">
+              <a:buNone/>
               <a:defRPr sz="1725" b="0">
                 <a:solidFill>
                   <a:srgbClr val="536563"/>
@@ -3657,7 +3721,13 @@
       </p:grpSpPr>
       <p:cxnSp>
         <p:nvCxnSpPr>
-          <p:cNvPr id="26" name=""/>
+          <p:cNvPr id="26" name="">
+            <a:extLst xmlns:a="http://schemas.openxmlformats.org/drawingml/2006/main">
+              <a:ext uri="{FF2B5EF4-FFF2-40B4-BE49-F238E27FC236}">
+                <a16:creationId xmlns:a16="http://schemas.microsoft.com/office/drawing/2014/main" id="{0542C0DA-62E3-4236-A481-71A52E0626CE}"/>
+              </a:ext>
+            </a:extLst>
+          </p:cNvPr>
           <p:cNvCxnSpPr>
             <a:stCxn xmlns:a="http://schemas.openxmlformats.org/drawingml/2006/main" id="11" idx="2"/>
             <a:endCxn xmlns:a="http://schemas.openxmlformats.org/drawingml/2006/main" id="18" idx="0"/>
@@ -3687,7 +3757,13 @@
       </p:cxnSp>
       <p:cxnSp>
         <p:nvCxnSpPr>
-          <p:cNvPr id="27" name=""/>
+          <p:cNvPr id="27" name="">
+            <a:extLst xmlns:a="http://schemas.openxmlformats.org/drawingml/2006/main">
+              <a:ext uri="{FF2B5EF4-FFF2-40B4-BE49-F238E27FC236}">
+                <a16:creationId xmlns:a16="http://schemas.microsoft.com/office/drawing/2014/main" id="{113657C3-FCEA-4C06-BE5A-79D7114EC13F}"/>
+              </a:ext>
+            </a:extLst>
+          </p:cNvPr>
           <p:cNvCxnSpPr>
             <a:stCxn xmlns:a="http://schemas.openxmlformats.org/drawingml/2006/main" id="8" idx="2"/>
             <a:endCxn xmlns:a="http://schemas.openxmlformats.org/drawingml/2006/main" id="17" idx="0"/>
@@ -3717,7 +3793,13 @@
       </p:cxnSp>
       <p:cxnSp>
         <p:nvCxnSpPr>
-          <p:cNvPr id="28" name=""/>
+          <p:cNvPr id="28" name="">
+            <a:extLst xmlns:a="http://schemas.openxmlformats.org/drawingml/2006/main">
+              <a:ext uri="{FF2B5EF4-FFF2-40B4-BE49-F238E27FC236}">
+                <a16:creationId xmlns:a16="http://schemas.microsoft.com/office/drawing/2014/main" id="{F1F0CD15-0903-49F4-85AD-5A674B16617C}"/>
+              </a:ext>
+            </a:extLst>
+          </p:cNvPr>
           <p:cNvCxnSpPr>
             <a:stCxn xmlns:a="http://schemas.openxmlformats.org/drawingml/2006/main" id="17" idx="3"/>
             <a:endCxn xmlns:a="http://schemas.openxmlformats.org/drawingml/2006/main" id="18" idx="1"/>
@@ -3744,7 +3826,13 @@
       </p:cxnSp>
       <p:cxnSp>
         <p:nvCxnSpPr>
-          <p:cNvPr id="29" name=""/>
+          <p:cNvPr id="29" name="">
+            <a:extLst xmlns:a="http://schemas.openxmlformats.org/drawingml/2006/main">
+              <a:ext uri="{FF2B5EF4-FFF2-40B4-BE49-F238E27FC236}">
+                <a16:creationId xmlns:a16="http://schemas.microsoft.com/office/drawing/2014/main" id="{9D823F7A-C877-4E00-AE68-FF9590C6CFB7}"/>
+              </a:ext>
+            </a:extLst>
+          </p:cNvPr>
           <p:cNvCxnSpPr>
             <a:stCxn xmlns:a="http://schemas.openxmlformats.org/drawingml/2006/main" id="16" idx="3"/>
             <a:endCxn xmlns:a="http://schemas.openxmlformats.org/drawingml/2006/main" id="17" idx="1"/>
@@ -3771,7 +3859,13 @@
       </p:cxnSp>
       <p:cxnSp>
         <p:nvCxnSpPr>
-          <p:cNvPr id="30" name=""/>
+          <p:cNvPr id="30" name="">
+            <a:extLst xmlns:a="http://schemas.openxmlformats.org/drawingml/2006/main">
+              <a:ext uri="{FF2B5EF4-FFF2-40B4-BE49-F238E27FC236}">
+                <a16:creationId xmlns:a16="http://schemas.microsoft.com/office/drawing/2014/main" id="{3698A58C-7E46-4A5D-84CF-AF6649D7882F}"/>
+              </a:ext>
+            </a:extLst>
+          </p:cNvPr>
           <p:cNvCxnSpPr>
             <a:stCxn xmlns:a="http://schemas.openxmlformats.org/drawingml/2006/main" id="5" idx="2"/>
             <a:endCxn xmlns:a="http://schemas.openxmlformats.org/drawingml/2006/main" id="9" idx="0"/>
@@ -3801,7 +3895,13 @@
       </p:cxnSp>
       <p:cxnSp>
         <p:nvCxnSpPr>
-          <p:cNvPr id="31" name=""/>
+          <p:cNvPr id="31" name="">
+            <a:extLst xmlns:a="http://schemas.openxmlformats.org/drawingml/2006/main">
+              <a:ext uri="{FF2B5EF4-FFF2-40B4-BE49-F238E27FC236}">
+                <a16:creationId xmlns:a16="http://schemas.microsoft.com/office/drawing/2014/main" id="{425E7DFE-312F-43DC-984E-3D3C943EE863}"/>
+              </a:ext>
+            </a:extLst>
+          </p:cNvPr>
           <p:cNvCxnSpPr>
             <a:stCxn xmlns:a="http://schemas.openxmlformats.org/drawingml/2006/main" id="10" idx="3"/>
             <a:endCxn xmlns:a="http://schemas.openxmlformats.org/drawingml/2006/main" id="11" idx="1"/>
@@ -3828,7 +3928,13 @@
       </p:cxnSp>
       <p:cxnSp>
         <p:nvCxnSpPr>
-          <p:cNvPr id="32" name=""/>
+          <p:cNvPr id="32" name="">
+            <a:extLst xmlns:a="http://schemas.openxmlformats.org/drawingml/2006/main">
+              <a:ext uri="{FF2B5EF4-FFF2-40B4-BE49-F238E27FC236}">
+                <a16:creationId xmlns:a16="http://schemas.microsoft.com/office/drawing/2014/main" id="{432AE780-3F48-4262-9045-E4DD0C77EB20}"/>
+              </a:ext>
+            </a:extLst>
+          </p:cNvPr>
           <p:cNvCxnSpPr>
             <a:stCxn xmlns:a="http://schemas.openxmlformats.org/drawingml/2006/main" id="9" idx="3"/>
             <a:endCxn xmlns:a="http://schemas.openxmlformats.org/drawingml/2006/main" id="10" idx="1"/>
@@ -3855,7 +3961,13 @@
       </p:cxnSp>
       <p:cxnSp>
         <p:nvCxnSpPr>
-          <p:cNvPr id="33" name=""/>
+          <p:cNvPr id="33" name="">
+            <a:extLst xmlns:a="http://schemas.openxmlformats.org/drawingml/2006/main">
+              <a:ext uri="{FF2B5EF4-FFF2-40B4-BE49-F238E27FC236}">
+                <a16:creationId xmlns:a16="http://schemas.microsoft.com/office/drawing/2014/main" id="{AD1812CF-928B-4E79-B6FE-8DCAC41D7618}"/>
+              </a:ext>
+            </a:extLst>
+          </p:cNvPr>
           <p:cNvCxnSpPr>
             <a:stCxn xmlns:a="http://schemas.openxmlformats.org/drawingml/2006/main" id="8" idx="3"/>
             <a:endCxn xmlns:a="http://schemas.openxmlformats.org/drawingml/2006/main" id="9" idx="1"/>
@@ -3882,7 +3994,13 @@
       </p:cxnSp>
       <p:cxnSp>
         <p:nvCxnSpPr>
-          <p:cNvPr id="34" name=""/>
+          <p:cNvPr id="34" name="">
+            <a:extLst xmlns:a="http://schemas.openxmlformats.org/drawingml/2006/main">
+              <a:ext uri="{FF2B5EF4-FFF2-40B4-BE49-F238E27FC236}">
+                <a16:creationId xmlns:a16="http://schemas.microsoft.com/office/drawing/2014/main" id="{CDB59689-5C6B-4D47-AEF8-4D86686022A7}"/>
+              </a:ext>
+            </a:extLst>
+          </p:cNvPr>
           <p:cNvCxnSpPr>
             <a:stCxn xmlns:a="http://schemas.openxmlformats.org/drawingml/2006/main" id="4" idx="3"/>
             <a:endCxn xmlns:a="http://schemas.openxmlformats.org/drawingml/2006/main" id="5" idx="1"/>
@@ -3909,7 +4027,13 @@
       </p:cxnSp>
       <p:cxnSp>
         <p:nvCxnSpPr>
-          <p:cNvPr id="35" name=""/>
+          <p:cNvPr id="35" name="">
+            <a:extLst xmlns:a="http://schemas.openxmlformats.org/drawingml/2006/main">
+              <a:ext uri="{FF2B5EF4-FFF2-40B4-BE49-F238E27FC236}">
+                <a16:creationId xmlns:a16="http://schemas.microsoft.com/office/drawing/2014/main" id="{67DBCFF6-2FBB-4508-A18C-FDBB5424519C}"/>
+              </a:ext>
+            </a:extLst>
+          </p:cNvPr>
           <p:cNvCxnSpPr>
             <a:stCxn xmlns:a="http://schemas.openxmlformats.org/drawingml/2006/main" id="3" idx="3"/>
             <a:endCxn xmlns:a="http://schemas.openxmlformats.org/drawingml/2006/main" id="4" idx="1"/>
@@ -3968,6 +4092,7 @@
           <a:lstStyle xmlns:a="http://schemas.openxmlformats.org/drawingml/2006/main"/>
           <a:p xmlns:a="http://schemas.openxmlformats.org/drawingml/2006/main">
             <a:pPr algn="l">
+              <a:buNone/>
               <a:defRPr sz="3300" b="1">
                 <a:solidFill>
                   <a:srgbClr val="142B2A"/>
@@ -4025,6 +4150,7 @@
           <a:lstStyle xmlns:a="http://schemas.openxmlformats.org/drawingml/2006/main"/>
           <a:p xmlns:a="http://schemas.openxmlformats.org/drawingml/2006/main">
             <a:pPr algn="r">
+              <a:buNone/>
               <a:defRPr sz="1500" b="0">
                 <a:solidFill>
                   <a:srgbClr val="536563"/>
@@ -4086,6 +4212,7 @@
           <a:lstStyle xmlns:a="http://schemas.openxmlformats.org/drawingml/2006/main"/>
           <a:p xmlns:a="http://schemas.openxmlformats.org/drawingml/2006/main">
             <a:pPr algn="ctr">
+              <a:buNone/>
               <a:defRPr sz="1800" b="0">
                 <a:solidFill>
                   <a:srgbClr val="142B2A"/>
@@ -4109,6 +4236,7 @@
           </a:p>
           <a:p xmlns:a="http://schemas.openxmlformats.org/drawingml/2006/main">
             <a:pPr algn="ctr">
+              <a:buNone/>
               <a:defRPr sz="1800" b="0">
                 <a:solidFill>
                   <a:srgbClr val="142B2A"/>
@@ -4170,6 +4298,7 @@
           <a:lstStyle xmlns:a="http://schemas.openxmlformats.org/drawingml/2006/main"/>
           <a:p xmlns:a="http://schemas.openxmlformats.org/drawingml/2006/main">
             <a:pPr algn="ctr">
+              <a:buNone/>
               <a:defRPr sz="1800" b="0">
                 <a:solidFill>
                   <a:srgbClr val="142B2A"/>
@@ -4193,6 +4322,7 @@
           </a:p>
           <a:p xmlns:a="http://schemas.openxmlformats.org/drawingml/2006/main">
             <a:pPr algn="ctr">
+              <a:buNone/>
               <a:defRPr sz="1800" b="0">
                 <a:solidFill>
                   <a:srgbClr val="142B2A"/>
@@ -4254,6 +4384,7 @@
           <a:lstStyle xmlns:a="http://schemas.openxmlformats.org/drawingml/2006/main"/>
           <a:p xmlns:a="http://schemas.openxmlformats.org/drawingml/2006/main">
             <a:pPr algn="ctr">
+              <a:buNone/>
               <a:defRPr sz="1800" b="0">
                 <a:solidFill>
                   <a:srgbClr val="142B2A"/>
@@ -4277,6 +4408,7 @@
           </a:p>
           <a:p xmlns:a="http://schemas.openxmlformats.org/drawingml/2006/main">
             <a:pPr algn="ctr">
+              <a:buNone/>
               <a:defRPr sz="1800" b="0">
                 <a:solidFill>
                   <a:srgbClr val="142B2A"/>
@@ -4338,6 +4470,7 @@
           <a:lstStyle xmlns:a="http://schemas.openxmlformats.org/drawingml/2006/main"/>
           <a:p xmlns:a="http://schemas.openxmlformats.org/drawingml/2006/main">
             <a:pPr algn="ctr">
+              <a:buNone/>
               <a:defRPr sz="1800" b="0">
                 <a:solidFill>
                   <a:srgbClr val="142B2A"/>
@@ -4361,6 +4494,7 @@
           </a:p>
           <a:p xmlns:a="http://schemas.openxmlformats.org/drawingml/2006/main">
             <a:pPr algn="ctr">
+              <a:buNone/>
               <a:defRPr sz="1800" b="0">
                 <a:solidFill>
                   <a:srgbClr val="142B2A"/>
@@ -4422,6 +4556,7 @@
           <a:lstStyle xmlns:a="http://schemas.openxmlformats.org/drawingml/2006/main"/>
           <a:p xmlns:a="http://schemas.openxmlformats.org/drawingml/2006/main">
             <a:pPr algn="ctr">
+              <a:buNone/>
               <a:defRPr sz="1800" b="0">
                 <a:solidFill>
                   <a:srgbClr val="142B2A"/>
@@ -4445,6 +4580,7 @@
           </a:p>
           <a:p xmlns:a="http://schemas.openxmlformats.org/drawingml/2006/main">
             <a:pPr algn="ctr">
+              <a:buNone/>
               <a:defRPr sz="1800" b="0">
                 <a:solidFill>
                   <a:srgbClr val="142B2A"/>
@@ -4506,6 +4642,7 @@
           <a:lstStyle xmlns:a="http://schemas.openxmlformats.org/drawingml/2006/main"/>
           <a:p xmlns:a="http://schemas.openxmlformats.org/drawingml/2006/main">
             <a:pPr algn="ctr">
+              <a:buNone/>
               <a:defRPr sz="1800" b="0">
                 <a:solidFill>
                   <a:srgbClr val="142B2A"/>
@@ -4529,6 +4666,7 @@
           </a:p>
           <a:p xmlns:a="http://schemas.openxmlformats.org/drawingml/2006/main">
             <a:pPr algn="ctr">
+              <a:buNone/>
               <a:defRPr sz="1800" b="0">
                 <a:solidFill>
                   <a:srgbClr val="142B2A"/>
@@ -4590,6 +4728,7 @@
           <a:lstStyle xmlns:a="http://schemas.openxmlformats.org/drawingml/2006/main"/>
           <a:p xmlns:a="http://schemas.openxmlformats.org/drawingml/2006/main">
             <a:pPr algn="ctr">
+              <a:buNone/>
               <a:defRPr sz="1800" b="0">
                 <a:solidFill>
                   <a:srgbClr val="FFFFFF"/>
@@ -4613,6 +4752,7 @@
           </a:p>
           <a:p xmlns:a="http://schemas.openxmlformats.org/drawingml/2006/main">
             <a:pPr algn="ctr">
+              <a:buNone/>
               <a:defRPr sz="1800" b="0">
                 <a:solidFill>
                   <a:srgbClr val="FFFFFF"/>
@@ -4674,6 +4814,7 @@
           <a:lstStyle xmlns:a="http://schemas.openxmlformats.org/drawingml/2006/main"/>
           <a:p xmlns:a="http://schemas.openxmlformats.org/drawingml/2006/main">
             <a:pPr algn="ctr">
+              <a:buNone/>
               <a:defRPr sz="1800" b="0">
                 <a:solidFill>
                   <a:srgbClr val="142B2A"/>
@@ -4697,6 +4838,7 @@
           </a:p>
           <a:p xmlns:a="http://schemas.openxmlformats.org/drawingml/2006/main">
             <a:pPr algn="ctr">
+              <a:buNone/>
               <a:defRPr sz="1800" b="0">
                 <a:solidFill>
                   <a:srgbClr val="142B2A"/>
@@ -4758,6 +4900,7 @@
           <a:lstStyle xmlns:a="http://schemas.openxmlformats.org/drawingml/2006/main"/>
           <a:p xmlns:a="http://schemas.openxmlformats.org/drawingml/2006/main">
             <a:pPr algn="ctr">
+              <a:buNone/>
               <a:defRPr sz="1800" b="0">
                 <a:solidFill>
                   <a:srgbClr val="FFFFFF"/>
@@ -4781,6 +4924,7 @@
           </a:p>
           <a:p xmlns:a="http://schemas.openxmlformats.org/drawingml/2006/main">
             <a:pPr algn="ctr">
+              <a:buNone/>
               <a:defRPr sz="1800" b="0">
                 <a:solidFill>
                   <a:srgbClr val="FFFFFF"/>
@@ -4842,6 +4986,7 @@
           <a:lstStyle xmlns:a="http://schemas.openxmlformats.org/drawingml/2006/main"/>
           <a:p xmlns:a="http://schemas.openxmlformats.org/drawingml/2006/main">
             <a:pPr algn="ctr">
+              <a:buNone/>
               <a:defRPr sz="1800" b="0">
                 <a:solidFill>
                   <a:srgbClr val="142B2A"/>
@@ -4865,6 +5010,7 @@
           </a:p>
           <a:p xmlns:a="http://schemas.openxmlformats.org/drawingml/2006/main">
             <a:pPr algn="ctr">
+              <a:buNone/>
               <a:defRPr sz="1800" b="0">
                 <a:solidFill>
                   <a:srgbClr val="142B2A"/>
@@ -4922,6 +5068,7 @@
           <a:lstStyle xmlns:a="http://schemas.openxmlformats.org/drawingml/2006/main"/>
           <a:p xmlns:a="http://schemas.openxmlformats.org/drawingml/2006/main">
             <a:pPr algn="l">
+              <a:buNone/>
               <a:defRPr sz="1725" b="0">
                 <a:solidFill>
                   <a:srgbClr val="24774F"/>
@@ -4979,6 +5126,7 @@
           <a:lstStyle xmlns:a="http://schemas.openxmlformats.org/drawingml/2006/main"/>
           <a:p xmlns:a="http://schemas.openxmlformats.org/drawingml/2006/main">
             <a:pPr algn="l">
+              <a:buNone/>
               <a:defRPr sz="1725" b="0">
                 <a:solidFill>
                   <a:srgbClr val="536563"/>
@@ -5036,6 +5184,7 @@
           <a:lstStyle xmlns:a="http://schemas.openxmlformats.org/drawingml/2006/main"/>
           <a:p xmlns:a="http://schemas.openxmlformats.org/drawingml/2006/main">
             <a:pPr algn="l">
+              <a:buNone/>
               <a:defRPr sz="1725" b="0">
                 <a:solidFill>
                   <a:srgbClr val="536563"/>
@@ -5122,6 +5271,7 @@
           <a:lstStyle xmlns:a="http://schemas.openxmlformats.org/drawingml/2006/main"/>
           <a:p xmlns:a="http://schemas.openxmlformats.org/drawingml/2006/main">
             <a:pPr algn="l">
+              <a:buNone/>
               <a:defRPr sz="3300" b="1">
                 <a:solidFill>
                   <a:srgbClr val="142B2A"/>
@@ -5179,6 +5329,7 @@
           <a:lstStyle xmlns:a="http://schemas.openxmlformats.org/drawingml/2006/main"/>
           <a:p xmlns:a="http://schemas.openxmlformats.org/drawingml/2006/main">
             <a:pPr algn="r">
+              <a:buNone/>
               <a:defRPr sz="1500" b="0">
                 <a:solidFill>
                   <a:srgbClr val="536563"/>
@@ -5236,6 +5387,7 @@
           <a:lstStyle xmlns:a="http://schemas.openxmlformats.org/drawingml/2006/main"/>
           <a:p xmlns:a="http://schemas.openxmlformats.org/drawingml/2006/main">
             <a:pPr algn="l">
+              <a:buNone/>
               <a:defRPr sz="7200" b="1">
                 <a:solidFill>
                   <a:srgbClr val="24774F"/>
@@ -5293,6 +5445,7 @@
           <a:lstStyle xmlns:a="http://schemas.openxmlformats.org/drawingml/2006/main"/>
           <a:p xmlns:a="http://schemas.openxmlformats.org/drawingml/2006/main">
             <a:pPr algn="l">
+              <a:buNone/>
               <a:defRPr sz="2400" b="0">
                 <a:solidFill>
                   <a:srgbClr val="142B2A"/>
@@ -5350,6 +5503,7 @@
           <a:lstStyle xmlns:a="http://schemas.openxmlformats.org/drawingml/2006/main"/>
           <a:p xmlns:a="http://schemas.openxmlformats.org/drawingml/2006/main">
             <a:pPr algn="l">
+              <a:buNone/>
               <a:defRPr sz="2100" b="0">
                 <a:solidFill>
                   <a:srgbClr val="536563"/>
@@ -5373,6 +5527,7 @@
           </a:p>
           <a:p xmlns:a="http://schemas.openxmlformats.org/drawingml/2006/main">
             <a:pPr algn="l">
+              <a:buNone/>
               <a:defRPr sz="2100" b="0">
                 <a:solidFill>
                   <a:srgbClr val="536563"/>
@@ -5430,6 +5585,7 @@
           <a:lstStyle xmlns:a="http://schemas.openxmlformats.org/drawingml/2006/main"/>
           <a:p xmlns:a="http://schemas.openxmlformats.org/drawingml/2006/main">
             <a:pPr algn="l">
+              <a:buNone/>
               <a:defRPr sz="2700" b="1">
                 <a:solidFill>
                   <a:srgbClr val="24774F"/>
@@ -5487,6 +5643,7 @@
           <a:lstStyle xmlns:a="http://schemas.openxmlformats.org/drawingml/2006/main"/>
           <a:p xmlns:a="http://schemas.openxmlformats.org/drawingml/2006/main">
             <a:pPr algn="l">
+              <a:buNone/>
               <a:defRPr sz="2100" b="0">
                 <a:solidFill>
                   <a:srgbClr val="142B2A"/>
@@ -5510,6 +5667,7 @@
           </a:p>
           <a:p xmlns:a="http://schemas.openxmlformats.org/drawingml/2006/main">
             <a:pPr algn="l">
+              <a:buNone/>
               <a:defRPr sz="2100" b="0">
                 <a:solidFill>
                   <a:srgbClr val="142B2A"/>
@@ -5533,6 +5691,7 @@
           </a:p>
           <a:p xmlns:a="http://schemas.openxmlformats.org/drawingml/2006/main">
             <a:pPr algn="l">
+              <a:buNone/>
               <a:defRPr sz="2100" b="0">
                 <a:solidFill>
                   <a:srgbClr val="142B2A"/>
@@ -5590,6 +5749,7 @@
           <a:lstStyle xmlns:a="http://schemas.openxmlformats.org/drawingml/2006/main"/>
           <a:p xmlns:a="http://schemas.openxmlformats.org/drawingml/2006/main">
             <a:pPr algn="l">
+              <a:buNone/>
               <a:defRPr sz="1950" b="0">
                 <a:solidFill>
                   <a:srgbClr val="536563"/>
@@ -5613,6 +5773,7 @@
           </a:p>
           <a:p xmlns:a="http://schemas.openxmlformats.org/drawingml/2006/main">
             <a:pPr algn="l">
+              <a:buNone/>
               <a:defRPr sz="1950" b="0">
                 <a:solidFill>
                   <a:srgbClr val="536563"/>
@@ -5636,6 +5797,7 @@
           </a:p>
           <a:p xmlns:a="http://schemas.openxmlformats.org/drawingml/2006/main">
             <a:pPr algn="l">
+              <a:buNone/>
               <a:defRPr sz="1950" b="0">
                 <a:solidFill>
                   <a:srgbClr val="536563"/>
@@ -5693,6 +5855,7 @@
           <a:lstStyle xmlns:a="http://schemas.openxmlformats.org/drawingml/2006/main"/>
           <a:p xmlns:a="http://schemas.openxmlformats.org/drawingml/2006/main">
             <a:pPr algn="l">
+              <a:buNone/>
               <a:defRPr sz="1725" b="0">
                 <a:solidFill>
                   <a:srgbClr val="536563"/>
@@ -5779,6 +5942,7 @@
           <a:lstStyle xmlns:a="http://schemas.openxmlformats.org/drawingml/2006/main"/>
           <a:p xmlns:a="http://schemas.openxmlformats.org/drawingml/2006/main">
             <a:pPr algn="l">
+              <a:buNone/>
               <a:defRPr sz="3300" b="1">
                 <a:solidFill>
                   <a:srgbClr val="142B2A"/>
@@ -5836,6 +6000,7 @@
           <a:lstStyle xmlns:a="http://schemas.openxmlformats.org/drawingml/2006/main"/>
           <a:p xmlns:a="http://schemas.openxmlformats.org/drawingml/2006/main">
             <a:pPr algn="r">
+              <a:buNone/>
               <a:defRPr sz="1500" b="0">
                 <a:solidFill>
                   <a:srgbClr val="536563"/>
@@ -5861,7 +6026,13 @@
       </p:sp>
       <p:graphicFrame>
         <p:nvGraphicFramePr>
-          <p:cNvPr id="8" name=""/>
+          <p:cNvPr id="8" name="">
+            <a:extLst xmlns:a="http://schemas.openxmlformats.org/drawingml/2006/main">
+              <a:ext uri="{FF2B5EF4-FFF2-40B4-BE49-F238E27FC236}">
+                <a16:creationId xmlns:a16="http://schemas.microsoft.com/office/drawing/2014/main" id="{101A7916-3E91-4642-B4DA-C69FA60DDEA4}"/>
+              </a:ext>
+            </a:extLst>
+          </p:cNvPr>
           <p:cNvGraphicFramePr/>
           <p:nvPr/>
         </p:nvGraphicFramePr>
@@ -6286,6 +6457,7 @@
           <a:lstStyle xmlns:a="http://schemas.openxmlformats.org/drawingml/2006/main"/>
           <a:p xmlns:a="http://schemas.openxmlformats.org/drawingml/2006/main">
             <a:pPr algn="l">
+              <a:buNone/>
               <a:defRPr sz="1950" b="0">
                 <a:solidFill>
                   <a:srgbClr val="24774F"/>
@@ -6343,6 +6515,7 @@
           <a:lstStyle xmlns:a="http://schemas.openxmlformats.org/drawingml/2006/main"/>
           <a:p xmlns:a="http://schemas.openxmlformats.org/drawingml/2006/main">
             <a:pPr algn="l">
+              <a:buNone/>
               <a:defRPr sz="1725" b="0">
                 <a:solidFill>
                   <a:srgbClr val="536563"/>
@@ -6429,6 +6602,7 @@
           <a:lstStyle xmlns:a="http://schemas.openxmlformats.org/drawingml/2006/main"/>
           <a:p xmlns:a="http://schemas.openxmlformats.org/drawingml/2006/main">
             <a:pPr algn="l">
+              <a:buNone/>
               <a:defRPr sz="3300" b="1">
                 <a:solidFill>
                   <a:srgbClr val="142B2A"/>
@@ -6486,6 +6660,7 @@
           <a:lstStyle xmlns:a="http://schemas.openxmlformats.org/drawingml/2006/main"/>
           <a:p xmlns:a="http://schemas.openxmlformats.org/drawingml/2006/main">
             <a:pPr algn="r">
+              <a:buNone/>
               <a:defRPr sz="1500" b="0">
                 <a:solidFill>
                   <a:srgbClr val="536563"/>
@@ -6511,7 +6686,13 @@
       </p:sp>
       <p:graphicFrame>
         <p:nvGraphicFramePr>
-          <p:cNvPr id="9" name=""/>
+          <p:cNvPr id="9" name="">
+            <a:extLst xmlns:a="http://schemas.openxmlformats.org/drawingml/2006/main">
+              <a:ext uri="{FF2B5EF4-FFF2-40B4-BE49-F238E27FC236}">
+                <a16:creationId xmlns:a16="http://schemas.microsoft.com/office/drawing/2014/main" id="{81954367-D9AE-4D1E-909A-0934E858935A}"/>
+              </a:ext>
+            </a:extLst>
+          </p:cNvPr>
           <p:cNvGraphicFramePr/>
           <p:nvPr/>
         </p:nvGraphicFramePr>
@@ -6862,6 +7043,7 @@
           <a:lstStyle xmlns:a="http://schemas.openxmlformats.org/drawingml/2006/main"/>
           <a:p xmlns:a="http://schemas.openxmlformats.org/drawingml/2006/main">
             <a:pPr algn="l">
+              <a:buNone/>
               <a:defRPr sz="2400" b="1">
                 <a:solidFill>
                   <a:srgbClr val="24774F"/>
@@ -6919,6 +7101,7 @@
           <a:lstStyle xmlns:a="http://schemas.openxmlformats.org/drawingml/2006/main"/>
           <a:p xmlns:a="http://schemas.openxmlformats.org/drawingml/2006/main">
             <a:pPr algn="l">
+              <a:buNone/>
               <a:defRPr sz="2025" b="0">
                 <a:solidFill>
                   <a:srgbClr val="142B2A"/>
@@ -6976,6 +7159,7 @@
           <a:lstStyle xmlns:a="http://schemas.openxmlformats.org/drawingml/2006/main"/>
           <a:p xmlns:a="http://schemas.openxmlformats.org/drawingml/2006/main">
             <a:pPr algn="l">
+              <a:buNone/>
               <a:defRPr sz="1650" b="0">
                 <a:solidFill>
                   <a:srgbClr val="536563"/>
@@ -7062,6 +7246,7 @@
           <a:lstStyle xmlns:a="http://schemas.openxmlformats.org/drawingml/2006/main"/>
           <a:p xmlns:a="http://schemas.openxmlformats.org/drawingml/2006/main">
             <a:pPr algn="l">
+              <a:buNone/>
               <a:defRPr sz="3300" b="1">
                 <a:solidFill>
                   <a:srgbClr val="142B2A"/>
@@ -7119,6 +7304,7 @@
           <a:lstStyle xmlns:a="http://schemas.openxmlformats.org/drawingml/2006/main"/>
           <a:p xmlns:a="http://schemas.openxmlformats.org/drawingml/2006/main">
             <a:pPr algn="r">
+              <a:buNone/>
               <a:defRPr sz="1500" b="0">
                 <a:solidFill>
                   <a:srgbClr val="536563"/>
@@ -7144,7 +7330,13 @@
       </p:sp>
       <p:graphicFrame>
         <p:nvGraphicFramePr>
-          <p:cNvPr id="9" name=""/>
+          <p:cNvPr id="9" name="">
+            <a:extLst xmlns:a="http://schemas.openxmlformats.org/drawingml/2006/main">
+              <a:ext uri="{FF2B5EF4-FFF2-40B4-BE49-F238E27FC236}">
+                <a16:creationId xmlns:a16="http://schemas.microsoft.com/office/drawing/2014/main" id="{F87CE901-E860-4018-B396-1B789361D48E}"/>
+              </a:ext>
+            </a:extLst>
+          </p:cNvPr>
           <p:cNvGraphicFramePr/>
           <p:nvPr/>
         </p:nvGraphicFramePr>
@@ -7421,6 +7613,7 @@
           <a:lstStyle xmlns:a="http://schemas.openxmlformats.org/drawingml/2006/main"/>
           <a:p xmlns:a="http://schemas.openxmlformats.org/drawingml/2006/main">
             <a:pPr algn="l">
+              <a:buNone/>
               <a:defRPr sz="2325" b="1">
                 <a:solidFill>
                   <a:srgbClr val="24774F"/>
@@ -7478,6 +7671,7 @@
           <a:lstStyle xmlns:a="http://schemas.openxmlformats.org/drawingml/2006/main"/>
           <a:p xmlns:a="http://schemas.openxmlformats.org/drawingml/2006/main">
             <a:pPr algn="l">
+              <a:buNone/>
               <a:defRPr sz="2100" b="0">
                 <a:solidFill>
                   <a:srgbClr val="142B2A"/>
@@ -7535,6 +7729,7 @@
           <a:lstStyle xmlns:a="http://schemas.openxmlformats.org/drawingml/2006/main"/>
           <a:p xmlns:a="http://schemas.openxmlformats.org/drawingml/2006/main">
             <a:pPr algn="l">
+              <a:buNone/>
               <a:defRPr sz="1650" b="0">
                 <a:solidFill>
                   <a:srgbClr val="536563"/>
@@ -7621,6 +7816,7 @@
           <a:lstStyle xmlns:a="http://schemas.openxmlformats.org/drawingml/2006/main"/>
           <a:p xmlns:a="http://schemas.openxmlformats.org/drawingml/2006/main">
             <a:pPr algn="l">
+              <a:buNone/>
               <a:defRPr sz="3300" b="1">
                 <a:solidFill>
                   <a:srgbClr val="142B2A"/>
@@ -7678,6 +7874,7 @@
           <a:lstStyle xmlns:a="http://schemas.openxmlformats.org/drawingml/2006/main"/>
           <a:p xmlns:a="http://schemas.openxmlformats.org/drawingml/2006/main">
             <a:pPr algn="r">
+              <a:buNone/>
               <a:defRPr sz="1500" b="0">
                 <a:solidFill>
                   <a:srgbClr val="536563"/>
@@ -7703,7 +7900,13 @@
       </p:sp>
       <p:graphicFrame>
         <p:nvGraphicFramePr>
-          <p:cNvPr id="9" name=""/>
+          <p:cNvPr id="9" name="">
+            <a:extLst xmlns:a="http://schemas.openxmlformats.org/drawingml/2006/main">
+              <a:ext uri="{FF2B5EF4-FFF2-40B4-BE49-F238E27FC236}">
+                <a16:creationId xmlns:a16="http://schemas.microsoft.com/office/drawing/2014/main" id="{087EB39E-DD39-45ED-BAA2-45849243182D}"/>
+              </a:ext>
+            </a:extLst>
+          </p:cNvPr>
           <p:cNvGraphicFramePr/>
           <p:nvPr/>
         </p:nvGraphicFramePr>
@@ -7980,6 +8183,7 @@
           <a:lstStyle xmlns:a="http://schemas.openxmlformats.org/drawingml/2006/main"/>
           <a:p xmlns:a="http://schemas.openxmlformats.org/drawingml/2006/main">
             <a:pPr algn="l">
+              <a:buNone/>
               <a:defRPr sz="2325" b="1">
                 <a:solidFill>
                   <a:srgbClr val="24774F"/>
@@ -8037,6 +8241,7 @@
           <a:lstStyle xmlns:a="http://schemas.openxmlformats.org/drawingml/2006/main"/>
           <a:p xmlns:a="http://schemas.openxmlformats.org/drawingml/2006/main">
             <a:pPr algn="l">
+              <a:buNone/>
               <a:defRPr sz="2025" b="0">
                 <a:solidFill>
                   <a:srgbClr val="142B2A"/>
@@ -8094,6 +8299,7 @@
           <a:lstStyle xmlns:a="http://schemas.openxmlformats.org/drawingml/2006/main"/>
           <a:p xmlns:a="http://schemas.openxmlformats.org/drawingml/2006/main">
             <a:pPr algn="l">
+              <a:buNone/>
               <a:defRPr sz="1650" b="0">
                 <a:solidFill>
                   <a:srgbClr val="536563"/>
@@ -8180,6 +8386,7 @@
           <a:lstStyle xmlns:a="http://schemas.openxmlformats.org/drawingml/2006/main"/>
           <a:p xmlns:a="http://schemas.openxmlformats.org/drawingml/2006/main">
             <a:pPr algn="l">
+              <a:buNone/>
               <a:defRPr sz="3300" b="1">
                 <a:solidFill>
                   <a:srgbClr val="142B2A"/>
@@ -8237,6 +8444,7 @@
           <a:lstStyle xmlns:a="http://schemas.openxmlformats.org/drawingml/2006/main"/>
           <a:p xmlns:a="http://schemas.openxmlformats.org/drawingml/2006/main">
             <a:pPr algn="r">
+              <a:buNone/>
               <a:defRPr sz="1500" b="0">
                 <a:solidFill>
                   <a:srgbClr val="536563"/>
@@ -8262,7 +8470,13 @@
       </p:sp>
       <p:graphicFrame>
         <p:nvGraphicFramePr>
-          <p:cNvPr id="8" name=""/>
+          <p:cNvPr id="8" name="">
+            <a:extLst xmlns:a="http://schemas.openxmlformats.org/drawingml/2006/main">
+              <a:ext uri="{FF2B5EF4-FFF2-40B4-BE49-F238E27FC236}">
+                <a16:creationId xmlns:a16="http://schemas.microsoft.com/office/drawing/2014/main" id="{92DB226A-8567-48A0-8986-827EA4B9AF6D}"/>
+              </a:ext>
+            </a:extLst>
+          </p:cNvPr>
           <p:cNvGraphicFramePr/>
           <p:nvPr/>
         </p:nvGraphicFramePr>
@@ -8516,6 +8730,7 @@
           <a:lstStyle xmlns:a="http://schemas.openxmlformats.org/drawingml/2006/main"/>
           <a:p xmlns:a="http://schemas.openxmlformats.org/drawingml/2006/main">
             <a:pPr algn="l">
+              <a:buNone/>
               <a:defRPr sz="2325" b="1">
                 <a:solidFill>
                   <a:srgbClr val="24774F"/>
@@ -8573,6 +8788,7 @@
           <a:lstStyle xmlns:a="http://schemas.openxmlformats.org/drawingml/2006/main"/>
           <a:p xmlns:a="http://schemas.openxmlformats.org/drawingml/2006/main">
             <a:pPr algn="l">
+              <a:buNone/>
               <a:defRPr sz="1725" b="0">
                 <a:solidFill>
                   <a:srgbClr val="536563"/>

</xml_diff>

<commit_message>
Humanize slide wording (slides 2, 4, 7, 10) and re-export the PDF
Same numbers and claims; plain title on slide 4, no slogan closer on slide 7, slide 10 no longer says the team caught the scorer error, editorial note removed.

Co-Authored-By: Claude Opus 5.5 <noreply@anthropic.com>
</commit_message>
<xml_diff>
--- a/presentation/MCQA_pitch_ready.pptx
+++ b/presentation/MCQA_pitch_ready.pptx
@@ -2550,7 +2550,7 @@
                 <a:ea typeface="Tahoma"/>
                 <a:cs typeface="Tahoma"/>
               </a:rPr>
-              <a:t>AI audit: decisions and an error we caught</a:t>
+              <a:t>AI audit: three decisions and one caught error</a:t>
             </a:r>
           </a:p>
         </p:txBody>
@@ -3038,7 +3038,7 @@
                 <a:ea typeface="Tahoma"/>
                 <a:cs typeface="Tahoma"/>
               </a:rPr>
-              <a:t>Claude Code and Codex built and checked the system. Human contributions must be recorded honestly.</a:t>
+              <a:t>Claude Code and Codex built and checked the system.</a:t>
             </a:r>
           </a:p>
         </p:txBody>
@@ -3521,7 +3521,7 @@
                 <a:ea typeface="Tahoma"/>
                 <a:cs typeface="Tahoma"/>
               </a:rPr>
-              <a:t>“How many iron ingots</a:t>
+              <a:t>"How many iron ingots</a:t>
             </a:r>
           </a:p>
           <a:p xmlns:a="http://schemas.openxmlformats.org/drawingml/2006/main">
@@ -3545,7 +3545,7 @@
                 <a:ea typeface="Tahoma"/>
                 <a:cs typeface="Tahoma"/>
               </a:rPr>
-              <a:t>for 3 hoppers?”</a:t>
+              <a:t>for 3 hoppers?"</a:t>
             </a:r>
           </a:p>
         </p:txBody>
@@ -5290,7 +5290,7 @@
                 <a:ea typeface="Tahoma"/>
                 <a:cs typeface="Tahoma"/>
               </a:rPr>
-              <a:t>Real pages, compact evidence</a:t>
+              <a:t>Corpus and chunking</a:t>
             </a:r>
           </a:p>
         </p:txBody>
@@ -5816,7 +5816,7 @@
                 <a:ea typeface="Tahoma"/>
                 <a:cs typeface="Tahoma"/>
               </a:rPr>
-              <a:t>were similar: 74.1%–74.5%.</a:t>
+              <a:t>were similar: 74.1% to 74.5%.</a:t>
             </a:r>
           </a:p>
         </p:txBody>
@@ -7690,7 +7690,7 @@
                 <a:ea typeface="Tahoma"/>
                 <a:cs typeface="Tahoma"/>
               </a:rPr>
-              <a:t>All 3 misses made no tool call. Routing still matters.</a:t>
+              <a:t>All 3 misses made no tool call, so routing is the weak point.</a:t>
             </a:r>
           </a:p>
         </p:txBody>

</xml_diff>